<commit_message>
Use TFF for 超滤 in the project glossary and UF retrofit English files
The project term for 超滤 is TFF, not ultrafiltration or UF. Record it in the
CMC glossary and apply it to the English PPT and checklist.

Co-authored-by: peterli0913 <peterli0913@users.noreply.github.com>
</commit_message>
<xml_diff>
--- a/deliverables/超滤设备改造_EN.pptx
+++ b/deliverables/超滤设备改造_EN.pptx
@@ -3791,7 +3791,7 @@
                 <a:cs typeface="Times New Roman"/>
                 <a:sym typeface="Impact" panose="020B0806030902050204" pitchFamily="34" charset="0"/>
               </a:rPr>
-              <a:t>Gap Identification – Ultrafiltration</a:t>
+              <a:t>Gap Identification – TFF</a:t>
             </a:r>
             <a:endParaRPr kumimoji="0" lang="en-US" sz="5400" b="1" i="0" u="none" strike="noStrike" kern="1200" cap="none" spc="0" normalizeH="0" baseline="0" noProof="0">
               <a:ln>
@@ -8154,7 +8154,7 @@
                           <a:ea typeface="Times New Roman"/>
                           <a:cs typeface="Times New Roman"/>
                         </a:rPr>
-                        <a:t>UF Skid</a:t>
+                        <a:t>TFF Skid</a:t>
                       </a:r>
                       <a:endParaRPr lang="en-US" sz="1200">
                         <a:latin typeface="Times New Roman"/>
@@ -13337,7 +13337,7 @@
                           <a:ea typeface="Times New Roman"/>
                           <a:cs typeface="Times New Roman"/>
                         </a:rPr>
-                        <a:t>Methanol and Prep Fraction Feed to UF</a:t>
+                        <a:t>Methanol and Prep Fraction Feed to TFF</a:t>
                       </a:r>
                       <a:endParaRPr lang="en-US" sz="800" b="1" i="0" u="none" strike="noStrike">
                         <a:solidFill>

</xml_diff>